<commit_message>
Bayard Jeunesse : slides alignées sur le catalogue d'abonnements
Co-Authored-By: Claude Opus 5.5 <noreply@anthropic.com>
Claude-Session: https://claude.ai/code/session_01BmxtdWjbeRUyPx9e1qVLbT
</commit_message>
<xml_diff>
--- a/rapports/septembre/Bayard_Jeunesse_sept2026.pptx
+++ b/rapports/septembre/Bayard_Jeunesse_sept2026.pptx
@@ -5289,7 +5289,7 @@
                 </a:solidFill>
                 <a:latin typeface="Arial"/>
               </a:rPr>
-              <a:t>livres papier</a:t>
+              <a:t>abonnement magazine</a:t>
             </a:r>
             <a:r>
               <a:rPr sz="1600" b="1" i="0">
@@ -5298,7 +5298,7 @@
                 </a:solidFill>
                 <a:latin typeface="Arial"/>
               </a:rPr>
-              <a:t>   abonnement</a:t>
+              <a:t>   J'aime lire</a:t>
             </a:r>
           </a:p>
           <a:p>
@@ -5314,7 +5314,7 @@
                 </a:solidFill>
                 <a:latin typeface="Arial"/>
               </a:rPr>
-              <a:t>magazine</a:t>
+              <a:t>Pomme d'Api</a:t>
             </a:r>
             <a:r>
               <a:rPr sz="1400" b="1" i="0">
@@ -5323,7 +5323,7 @@
                 </a:solidFill>
                 <a:latin typeface="Arial"/>
               </a:rPr>
-              <a:t>   audiobook</a:t>
+              <a:t>   Phosphore</a:t>
             </a:r>
           </a:p>
           <a:p>
@@ -5339,7 +5339,7 @@
                 </a:solidFill>
                 <a:latin typeface="Arial"/>
               </a:rPr>
-              <a:t>numéros numériques</a:t>
+              <a:t>Images Doc</a:t>
             </a:r>
             <a:r>
               <a:rPr sz="1200" b="0" i="0">
@@ -5348,7 +5348,7 @@
                 </a:solidFill>
                 <a:latin typeface="Arial"/>
               </a:rPr>
-              <a:t>   BD</a:t>
+              <a:t>   Popi</a:t>
             </a:r>
           </a:p>
           <a:p>
@@ -5364,7 +5364,7 @@
                 </a:solidFill>
                 <a:latin typeface="Arial"/>
               </a:rPr>
-              <a:t>Nathan</a:t>
+              <a:t>I Love English</a:t>
             </a:r>
             <a:r>
               <a:rPr sz="1100" b="1" i="0">
@@ -5373,7 +5373,7 @@
                 </a:solidFill>
                 <a:latin typeface="Arial"/>
               </a:rPr>
-              <a:t>   Mon Quotidien</a:t>
+              <a:t>   So Foot Club</a:t>
             </a:r>
           </a:p>
           <a:p>
@@ -5389,7 +5389,7 @@
                 </a:solidFill>
                 <a:latin typeface="Arial"/>
               </a:rPr>
-              <a:t>Glénat</a:t>
+              <a:t>Okapi</a:t>
             </a:r>
             <a:r>
               <a:rPr sz="1100" b="0" i="0">
@@ -5398,16 +5398,16 @@
                 </a:solidFill>
                 <a:latin typeface="Arial"/>
               </a:rPr>
-              <a:t>   Fleurus</a:t>
-            </a:r>
-            <a:r>
-              <a:rPr sz="1100" b="0" i="0">
+              <a:t>   Astrapi</a:t>
+            </a:r>
+            <a:r>
+              <a:rPr sz="1100" b="1" i="0">
                 <a:solidFill>
                   <a:srgbClr val="EE6A2C"/>
                 </a:solidFill>
                 <a:latin typeface="Arial"/>
               </a:rPr>
-              <a:t>   Milan Presse</a:t>
+              <a:t>   Youpi Doc</a:t>
             </a:r>
           </a:p>
           <a:p>
@@ -5423,7 +5423,7 @@
                 </a:solidFill>
                 <a:latin typeface="Arial"/>
               </a:rPr>
-              <a:t>livres audio</a:t>
+              <a:t>livré à la maison</a:t>
             </a:r>
             <a:r>
               <a:rPr sz="1100" b="0" i="0">
@@ -5432,7 +5432,7 @@
                 </a:solidFill>
                 <a:latin typeface="Arial"/>
               </a:rPr>
-              <a:t>   Spotify</a:t>
+              <a:t>   numérique</a:t>
             </a:r>
           </a:p>
         </p:txBody>
@@ -5616,7 +5616,7 @@
                 </a:solidFill>
                 <a:latin typeface="Arial"/>
               </a:rPr>
-              <a:t>Ça vaut le coup en audiobook ou mieux en lecture papier ?</a:t>
+              <a:t>Comment je m'abonne pour accéder aux numéros numériques ?</a:t>
             </a:r>
           </a:p>
         </p:txBody>
@@ -5730,7 +5730,7 @@
                 </a:solidFill>
                 <a:latin typeface="Arial"/>
               </a:rPr>
-              <a:t>Où je peux acheter le livre et à quel prix ?</a:t>
+              <a:t>Comment je reçois le magazine papier chez moi ?</a:t>
             </a:r>
           </a:p>
         </p:txBody>
@@ -5844,52 +5844,43 @@
                 </a:solidFill>
                 <a:latin typeface="Arial"/>
               </a:rPr>
-              <a:t>Comment je m'abonne pour accéder aux numéros numériques ?</a:t>
-            </a:r>
-          </a:p>
-        </p:txBody>
-      </p:sp>
-      <p:sp>
-        <p:nvSpPr>
-          <p:cNvPr id="71" name="Rectangle 70"/>
-          <p:cNvSpPr/>
-          <p:nvPr/>
-        </p:nvSpPr>
-        <p:spPr>
-          <a:xfrm>
-            <a:off x="4437888" y="5364480"/>
-            <a:ext cx="2913888" cy="304800"/>
-          </a:xfrm>
-          <a:prstGeom prst="rect">
-            <a:avLst/>
-          </a:prstGeom>
-          <a:solidFill>
-            <a:srgbClr val="F1EFEA"/>
-          </a:solidFill>
-          <a:ln>
-            <a:noFill/>
-          </a:ln>
-          <a:effectLst/>
-        </p:spPr>
-        <p:style>
-          <a:lnRef idx="1">
-            <a:schemeClr val="accent1"/>
-          </a:lnRef>
-          <a:fillRef idx="3">
-            <a:schemeClr val="accent1"/>
-          </a:fillRef>
-          <a:effectRef idx="2">
-            <a:schemeClr val="accent1"/>
-          </a:effectRef>
-          <a:fontRef idx="minor">
-            <a:schemeClr val="lt1"/>
-          </a:fontRef>
-        </p:style>
-        <p:txBody>
-          <a:bodyPr rtlCol="0" anchor="ctr"/>
-          <a:lstStyle/>
-          <a:p>
-            <a:pPr algn="ctr"/>
+              <a:t>Ça vaut le coup en audiobook ou mieux en lecture papier ?</a:t>
+            </a:r>
+          </a:p>
+        </p:txBody>
+      </p:sp>
+      <p:sp>
+        <p:nvSpPr>
+          <p:cNvPr id="71" name="TextBox 70"/>
+          <p:cNvSpPr txBox="1"/>
+          <p:nvPr/>
+        </p:nvSpPr>
+        <p:spPr>
+          <a:xfrm>
+            <a:off x="8101584" y="3767328"/>
+            <a:ext cx="2926080" cy="152400"/>
+          </a:xfrm>
+          <a:prstGeom prst="rect">
+            <a:avLst/>
+          </a:prstGeom>
+          <a:noFill/>
+        </p:spPr>
+        <p:txBody>
+          <a:bodyPr wrap="square" anchor="t" lIns="0" rIns="0" tIns="0" bIns="0">
+            <a:spAutoFit/>
+          </a:bodyPr>
+          <a:lstStyle/>
+          <a:p>
+            <a:pPr algn="l"/>
+            <a:r>
+              <a:rPr sz="1300" b="1" i="0">
+                <a:solidFill>
+                  <a:srgbClr val="555B66"/>
+                </a:solidFill>
+                <a:latin typeface="Arial"/>
+              </a:rPr>
+              <a:t>CATÉGORIES DE PRODUITS</a:t>
+            </a:r>
           </a:p>
         </p:txBody>
       </p:sp>
@@ -5901,8 +5892,8 @@
         </p:nvSpPr>
         <p:spPr>
           <a:xfrm>
-            <a:off x="4559808" y="5364480"/>
-            <a:ext cx="182880" cy="304800"/>
+            <a:off x="8101584" y="3992880"/>
+            <a:ext cx="2926080" cy="121920"/>
           </a:xfrm>
           <a:prstGeom prst="rect">
             <a:avLst/>
@@ -5910,20 +5901,20 @@
           <a:noFill/>
         </p:spPr>
         <p:txBody>
-          <a:bodyPr wrap="square" anchor="ctr" lIns="0" rIns="0" tIns="0" bIns="0">
+          <a:bodyPr wrap="square" anchor="t" lIns="0" rIns="0" tIns="0" bIns="0">
             <a:spAutoFit/>
           </a:bodyPr>
           <a:lstStyle/>
           <a:p>
             <a:pPr algn="l"/>
             <a:r>
-              <a:rPr sz="900" b="0" i="0">
-                <a:solidFill>
-                  <a:srgbClr val="555B66"/>
-                </a:solidFill>
-                <a:latin typeface="Arial"/>
-              </a:rPr>
-              <a:t>🔍</a:t>
+              <a:rPr sz="1000" b="0" i="1">
+                <a:solidFill>
+                  <a:srgbClr val="8A93A6"/>
+                </a:solidFill>
+                <a:latin typeface="Arial"/>
+              </a:rPr>
+              <a:t>Répartition des requêtes</a:t>
             </a:r>
           </a:p>
         </p:txBody>
@@ -5936,157 +5927,8 @@
         </p:nvSpPr>
         <p:spPr>
           <a:xfrm>
-            <a:off x="4791456" y="5364480"/>
-            <a:ext cx="2499360" cy="304800"/>
-          </a:xfrm>
-          <a:prstGeom prst="rect">
-            <a:avLst/>
-          </a:prstGeom>
-          <a:noFill/>
-        </p:spPr>
-        <p:txBody>
-          <a:bodyPr wrap="square" anchor="ctr" lIns="0" rIns="0" tIns="0" bIns="0">
-            <a:spAutoFit/>
-          </a:bodyPr>
-          <a:lstStyle/>
-          <a:p>
-            <a:pPr algn="l"/>
-            <a:r>
-              <a:rPr sz="900" b="0" i="0">
-                <a:solidFill>
-                  <a:srgbClr val="111111"/>
-                </a:solidFill>
-                <a:latin typeface="Arial"/>
-              </a:rPr>
-              <a:t>Comment je reçois le magazine papier chez moi ?</a:t>
-            </a:r>
-          </a:p>
-        </p:txBody>
-      </p:sp>
-      <p:sp>
-        <p:nvSpPr>
-          <p:cNvPr id="74" name="Rectangle 73"/>
-          <p:cNvSpPr/>
-          <p:nvPr/>
-        </p:nvSpPr>
-        <p:spPr>
-          <a:xfrm>
-            <a:off x="4437888" y="5730240"/>
-            <a:ext cx="2913888" cy="304800"/>
-          </a:xfrm>
-          <a:prstGeom prst="rect">
-            <a:avLst/>
-          </a:prstGeom>
-          <a:solidFill>
-            <a:srgbClr val="F1EFEA"/>
-          </a:solidFill>
-          <a:ln>
-            <a:noFill/>
-          </a:ln>
-          <a:effectLst/>
-        </p:spPr>
-        <p:style>
-          <a:lnRef idx="1">
-            <a:schemeClr val="accent1"/>
-          </a:lnRef>
-          <a:fillRef idx="3">
-            <a:schemeClr val="accent1"/>
-          </a:fillRef>
-          <a:effectRef idx="2">
-            <a:schemeClr val="accent1"/>
-          </a:effectRef>
-          <a:fontRef idx="minor">
-            <a:schemeClr val="lt1"/>
-          </a:fontRef>
-        </p:style>
-        <p:txBody>
-          <a:bodyPr rtlCol="0" anchor="ctr"/>
-          <a:lstStyle/>
-          <a:p>
-            <a:pPr algn="ctr"/>
-          </a:p>
-        </p:txBody>
-      </p:sp>
-      <p:sp>
-        <p:nvSpPr>
-          <p:cNvPr id="75" name="TextBox 74"/>
-          <p:cNvSpPr txBox="1"/>
-          <p:nvPr/>
-        </p:nvSpPr>
-        <p:spPr>
-          <a:xfrm>
-            <a:off x="4559808" y="5730240"/>
-            <a:ext cx="182880" cy="304800"/>
-          </a:xfrm>
-          <a:prstGeom prst="rect">
-            <a:avLst/>
-          </a:prstGeom>
-          <a:noFill/>
-        </p:spPr>
-        <p:txBody>
-          <a:bodyPr wrap="square" anchor="ctr" lIns="0" rIns="0" tIns="0" bIns="0">
-            <a:spAutoFit/>
-          </a:bodyPr>
-          <a:lstStyle/>
-          <a:p>
-            <a:pPr algn="l"/>
-            <a:r>
-              <a:rPr sz="900" b="0" i="0">
-                <a:solidFill>
-                  <a:srgbClr val="555B66"/>
-                </a:solidFill>
-                <a:latin typeface="Arial"/>
-              </a:rPr>
-              <a:t>🔍</a:t>
-            </a:r>
-          </a:p>
-        </p:txBody>
-      </p:sp>
-      <p:sp>
-        <p:nvSpPr>
-          <p:cNvPr id="76" name="TextBox 75"/>
-          <p:cNvSpPr txBox="1"/>
-          <p:nvPr/>
-        </p:nvSpPr>
-        <p:spPr>
-          <a:xfrm>
-            <a:off x="4791456" y="5730240"/>
-            <a:ext cx="2499360" cy="304800"/>
-          </a:xfrm>
-          <a:prstGeom prst="rect">
-            <a:avLst/>
-          </a:prstGeom>
-          <a:noFill/>
-        </p:spPr>
-        <p:txBody>
-          <a:bodyPr wrap="square" anchor="ctr" lIns="0" rIns="0" tIns="0" bIns="0">
-            <a:spAutoFit/>
-          </a:bodyPr>
-          <a:lstStyle/>
-          <a:p>
-            <a:pPr algn="l"/>
-            <a:r>
-              <a:rPr sz="900" b="0" i="0">
-                <a:solidFill>
-                  <a:srgbClr val="111111"/>
-                </a:solidFill>
-                <a:latin typeface="Arial"/>
-              </a:rPr>
-              <a:t>Montre-moi les livres audio disponibles sur Spotify</a:t>
-            </a:r>
-          </a:p>
-        </p:txBody>
-      </p:sp>
-      <p:sp>
-        <p:nvSpPr>
-          <p:cNvPr id="77" name="TextBox 76"/>
-          <p:cNvSpPr txBox="1"/>
-          <p:nvPr/>
-        </p:nvSpPr>
-        <p:spPr>
-          <a:xfrm>
-            <a:off x="8101584" y="3767328"/>
-            <a:ext cx="2926080" cy="152400"/>
+            <a:off x="10607040" y="4175760"/>
+            <a:ext cx="518160" cy="121920"/>
           </a:xfrm>
           <a:prstGeom prst="rect">
             <a:avLst/>
@@ -6099,76 +5941,6 @@
           </a:bodyPr>
           <a:lstStyle/>
           <a:p>
-            <a:pPr algn="l"/>
-            <a:r>
-              <a:rPr sz="1300" b="1" i="0">
-                <a:solidFill>
-                  <a:srgbClr val="555B66"/>
-                </a:solidFill>
-                <a:latin typeface="Arial"/>
-              </a:rPr>
-              <a:t>CATÉGORIES DE PRODUITS</a:t>
-            </a:r>
-          </a:p>
-        </p:txBody>
-      </p:sp>
-      <p:sp>
-        <p:nvSpPr>
-          <p:cNvPr id="78" name="TextBox 77"/>
-          <p:cNvSpPr txBox="1"/>
-          <p:nvPr/>
-        </p:nvSpPr>
-        <p:spPr>
-          <a:xfrm>
-            <a:off x="8101584" y="3992880"/>
-            <a:ext cx="2926080" cy="121920"/>
-          </a:xfrm>
-          <a:prstGeom prst="rect">
-            <a:avLst/>
-          </a:prstGeom>
-          <a:noFill/>
-        </p:spPr>
-        <p:txBody>
-          <a:bodyPr wrap="square" anchor="t" lIns="0" rIns="0" tIns="0" bIns="0">
-            <a:spAutoFit/>
-          </a:bodyPr>
-          <a:lstStyle/>
-          <a:p>
-            <a:pPr algn="l"/>
-            <a:r>
-              <a:rPr sz="1000" b="0" i="1">
-                <a:solidFill>
-                  <a:srgbClr val="8A93A6"/>
-                </a:solidFill>
-                <a:latin typeface="Arial"/>
-              </a:rPr>
-              <a:t>Répartition des requêtes</a:t>
-            </a:r>
-          </a:p>
-        </p:txBody>
-      </p:sp>
-      <p:sp>
-        <p:nvSpPr>
-          <p:cNvPr id="79" name="TextBox 78"/>
-          <p:cNvSpPr txBox="1"/>
-          <p:nvPr/>
-        </p:nvSpPr>
-        <p:spPr>
-          <a:xfrm>
-            <a:off x="10607040" y="4175760"/>
-            <a:ext cx="518160" cy="121920"/>
-          </a:xfrm>
-          <a:prstGeom prst="rect">
-            <a:avLst/>
-          </a:prstGeom>
-          <a:noFill/>
-        </p:spPr>
-        <p:txBody>
-          <a:bodyPr wrap="square" anchor="t" lIns="0" rIns="0" tIns="0" bIns="0">
-            <a:spAutoFit/>
-          </a:bodyPr>
-          <a:lstStyle/>
-          <a:p>
             <a:pPr algn="r"/>
             <a:r>
               <a:rPr sz="1100" b="1" i="0">
@@ -6184,7 +5956,7 @@
       </p:sp>
       <p:sp>
         <p:nvSpPr>
-          <p:cNvPr id="80" name="Rectangle 79"/>
+          <p:cNvPr id="74" name="Rectangle 73"/>
           <p:cNvSpPr/>
           <p:nvPr/>
         </p:nvSpPr>
@@ -6228,7 +6000,7 @@
       </p:sp>
       <p:sp>
         <p:nvSpPr>
-          <p:cNvPr id="81" name="TextBox 80"/>
+          <p:cNvPr id="75" name="TextBox 74"/>
           <p:cNvSpPr txBox="1"/>
           <p:nvPr/>
         </p:nvSpPr>
@@ -6263,7 +6035,7 @@
       </p:sp>
       <p:sp>
         <p:nvSpPr>
-          <p:cNvPr id="82" name="Rectangle 81"/>
+          <p:cNvPr id="76" name="Rectangle 75"/>
           <p:cNvSpPr/>
           <p:nvPr/>
         </p:nvSpPr>
@@ -6307,7 +6079,7 @@
       </p:sp>
       <p:sp>
         <p:nvSpPr>
-          <p:cNvPr id="83" name="TextBox 82"/>
+          <p:cNvPr id="77" name="TextBox 76"/>
           <p:cNvSpPr txBox="1"/>
           <p:nvPr/>
         </p:nvSpPr>
@@ -6335,14 +6107,14 @@
                 </a:solidFill>
                 <a:latin typeface="Arial"/>
               </a:rPr>
-              <a:t>Apprentissage de l'anglais · 3 %</a:t>
-            </a:r>
-          </a:p>
-        </p:txBody>
-      </p:sp>
-      <p:sp>
-        <p:nvSpPr>
-          <p:cNvPr id="84" name="Rectangle 83"/>
+              <a:t>Apprentissage de l'anglais · 8 %</a:t>
+            </a:r>
+          </a:p>
+        </p:txBody>
+      </p:sp>
+      <p:sp>
+        <p:nvSpPr>
+          <p:cNvPr id="78" name="Rectangle 77"/>
           <p:cNvSpPr/>
           <p:nvPr/>
         </p:nvSpPr>
@@ -6386,7 +6158,7 @@
       </p:sp>
       <p:sp>
         <p:nvSpPr>
-          <p:cNvPr id="85" name="TextBox 84"/>
+          <p:cNvPr id="79" name="TextBox 78"/>
           <p:cNvSpPr txBox="1"/>
           <p:nvPr/>
         </p:nvSpPr>
@@ -6414,14 +6186,14 @@
                 </a:solidFill>
                 <a:latin typeface="Arial"/>
               </a:rPr>
-              <a:t>Magazines pour adolescents · 16 %</a:t>
-            </a:r>
-          </a:p>
-        </p:txBody>
-      </p:sp>
-      <p:sp>
-        <p:nvSpPr>
-          <p:cNvPr id="86" name="Rectangle 85"/>
+              <a:t>Magazines pour adolescents · 19 %</a:t>
+            </a:r>
+          </a:p>
+        </p:txBody>
+      </p:sp>
+      <p:sp>
+        <p:nvSpPr>
+          <p:cNvPr id="80" name="Rectangle 79"/>
           <p:cNvSpPr/>
           <p:nvPr/>
         </p:nvSpPr>
@@ -6465,7 +6237,7 @@
       </p:sp>
       <p:sp>
         <p:nvSpPr>
-          <p:cNvPr id="87" name="TextBox 86"/>
+          <p:cNvPr id="81" name="TextBox 80"/>
           <p:cNvSpPr txBox="1"/>
           <p:nvPr/>
         </p:nvSpPr>
@@ -6493,21 +6265,21 @@
                 </a:solidFill>
                 <a:latin typeface="Arial"/>
               </a:rPr>
-              <a:t>Éveil et petite enfance · 11 %</a:t>
-            </a:r>
-          </a:p>
-        </p:txBody>
-      </p:sp>
-      <p:sp>
-        <p:nvSpPr>
-          <p:cNvPr id="88" name="Rectangle 87"/>
+              <a:t>Éveil et petite enfance · 40 %</a:t>
+            </a:r>
+          </a:p>
+        </p:txBody>
+      </p:sp>
+      <p:sp>
+        <p:nvSpPr>
+          <p:cNvPr id="82" name="Rectangle 81"/>
           <p:cNvSpPr/>
           <p:nvPr/>
         </p:nvSpPr>
         <p:spPr>
           <a:xfrm>
             <a:off x="10564368" y="4450080"/>
-            <a:ext cx="475488" cy="938784"/>
+            <a:ext cx="475488" cy="442569"/>
           </a:xfrm>
           <a:prstGeom prst="rect">
             <a:avLst/>
@@ -6544,14 +6316,14 @@
       </p:sp>
       <p:sp>
         <p:nvSpPr>
-          <p:cNvPr id="89" name="TextBox 88"/>
+          <p:cNvPr id="83" name="TextBox 82"/>
           <p:cNvSpPr txBox="1"/>
           <p:nvPr/>
         </p:nvSpPr>
         <p:spPr>
           <a:xfrm>
             <a:off x="10564368" y="4450080"/>
-            <a:ext cx="475488" cy="938784"/>
+            <a:ext cx="475488" cy="442569"/>
           </a:xfrm>
           <a:prstGeom prst="rect">
             <a:avLst/>
@@ -6572,21 +6344,21 @@
                 </a:solidFill>
                 <a:latin typeface="Arial"/>
               </a:rPr>
-              <a:t>70 %</a:t>
-            </a:r>
-          </a:p>
-        </p:txBody>
-      </p:sp>
-      <p:sp>
-        <p:nvSpPr>
-          <p:cNvPr id="90" name="Rectangle 89"/>
+              <a:t>33 %</a:t>
+            </a:r>
+          </a:p>
+        </p:txBody>
+      </p:sp>
+      <p:sp>
+        <p:nvSpPr>
+          <p:cNvPr id="84" name="Rectangle 83"/>
           <p:cNvSpPr/>
           <p:nvPr/>
         </p:nvSpPr>
         <p:spPr>
           <a:xfrm>
-            <a:off x="10564368" y="5388864"/>
-            <a:ext cx="475488" cy="40233"/>
+            <a:off x="10564368" y="4892649"/>
+            <a:ext cx="475488" cy="107289"/>
           </a:xfrm>
           <a:prstGeom prst="rect">
             <a:avLst/>
@@ -6623,14 +6395,14 @@
       </p:sp>
       <p:sp>
         <p:nvSpPr>
-          <p:cNvPr id="91" name="Rectangle 90"/>
+          <p:cNvPr id="85" name="Rectangle 84"/>
           <p:cNvSpPr/>
           <p:nvPr/>
         </p:nvSpPr>
         <p:spPr>
           <a:xfrm>
-            <a:off x="10564368" y="5429097"/>
-            <a:ext cx="475488" cy="214579"/>
+            <a:off x="10564368" y="4999939"/>
+            <a:ext cx="475488" cy="254812"/>
           </a:xfrm>
           <a:prstGeom prst="rect">
             <a:avLst/>
@@ -6667,14 +6439,14 @@
       </p:sp>
       <p:sp>
         <p:nvSpPr>
-          <p:cNvPr id="92" name="Rectangle 91"/>
+          <p:cNvPr id="86" name="Rectangle 85"/>
           <p:cNvSpPr/>
           <p:nvPr/>
         </p:nvSpPr>
         <p:spPr>
           <a:xfrm>
-            <a:off x="10564368" y="5643676"/>
-            <a:ext cx="475488" cy="147523"/>
+            <a:off x="10564368" y="5254752"/>
+            <a:ext cx="475488" cy="536448"/>
           </a:xfrm>
           <a:prstGeom prst="rect">
             <a:avLst/>
@@ -6706,6 +6478,41 @@
           <a:lstStyle/>
           <a:p>
             <a:pPr algn="ctr"/>
+          </a:p>
+        </p:txBody>
+      </p:sp>
+      <p:sp>
+        <p:nvSpPr>
+          <p:cNvPr id="87" name="TextBox 86"/>
+          <p:cNvSpPr txBox="1"/>
+          <p:nvPr/>
+        </p:nvSpPr>
+        <p:spPr>
+          <a:xfrm>
+            <a:off x="10564368" y="5254752"/>
+            <a:ext cx="475488" cy="536448"/>
+          </a:xfrm>
+          <a:prstGeom prst="rect">
+            <a:avLst/>
+          </a:prstGeom>
+          <a:noFill/>
+        </p:spPr>
+        <p:txBody>
+          <a:bodyPr wrap="square" anchor="ctr" lIns="0" rIns="0" tIns="0" bIns="0">
+            <a:spAutoFit/>
+          </a:bodyPr>
+          <a:lstStyle/>
+          <a:p>
+            <a:pPr algn="ctr"/>
+            <a:r>
+              <a:rPr sz="1000" b="1" i="0">
+                <a:solidFill>
+                  <a:srgbClr val="FFFFFF"/>
+                </a:solidFill>
+                <a:latin typeface="Arial"/>
+              </a:rPr>
+              <a:t>40 %</a:t>
+            </a:r>
           </a:p>
         </p:txBody>
       </p:sp>
@@ -7110,7 +6917,7 @@
                 </a:solidFill>
                 <a:latin typeface="Arial"/>
               </a:rPr>
-              <a:t>Mettre en avant les magazines découverte et actualité</a:t>
+              <a:t>Mettre en avant les magazines ados</a:t>
             </a:r>
           </a:p>
         </p:txBody>
@@ -7145,7 +6952,7 @@
                 </a:solidFill>
                 <a:latin typeface="Arial"/>
               </a:rPr>
-              <a:t>Images Doc (8-12 ans) et Phosphore (lycéens) atteignent plus de 2,2 fois le CTR moyen, les meilleurs scores de la campagne.</a:t>
+              <a:t>Les magazines pour adolescents (Phosphore, Okapi, So Foot Club, Je bouquine) atteignent 1,39 fois le CTR moyen. Phosphore atteint même 2,23 fois.</a:t>
             </a:r>
           </a:p>
         </p:txBody>
@@ -7180,7 +6987,7 @@
                 </a:solidFill>
                 <a:latin typeface="Arial"/>
               </a:rPr>
-              <a:t>→  Donner plus de visibilité aux titres qui aident à comprendre le monde et l'actualité.</a:t>
+              <a:t>→  Donner plus de place aux titres ados dans la diffusion.</a:t>
             </a:r>
           </a:p>
         </p:txBody>
@@ -7296,7 +7103,7 @@
                 </a:solidFill>
                 <a:latin typeface="Arial"/>
               </a:rPr>
-              <a:t>Parler d'un âge et d'un bénéfice précis</a:t>
+              <a:t>Les magazines documentaires surperforment</a:t>
             </a:r>
           </a:p>
         </p:txBody>
@@ -7331,7 +7138,7 @@
                 </a:solidFill>
                 <a:latin typeface="Arial"/>
               </a:rPr>
-              <a:t>Les annonces qui indiquent la tranche d'âge et ce que l'enfant y gagne (orientation, culture, lecture) dépassent la moyenne. L'abonnement générique reste à 1,02 fois.</a:t>
+              <a:t>Images Doc (magazine découvertes 8-12 ans) atteint 2,28 fois le CTR moyen, le meilleur score de la campagne.</a:t>
             </a:r>
           </a:p>
         </p:txBody>
@@ -7366,7 +7173,7 @@
                 </a:solidFill>
                 <a:latin typeface="Arial"/>
               </a:rPr>
-              <a:t>→  Construire chaque accroche autour d'un âge et d'un bénéfice concret.</a:t>
+              <a:t>→  Mettre en avant les titres qui aident à comprendre le monde.</a:t>
             </a:r>
           </a:p>
         </p:txBody>
@@ -7482,7 +7289,7 @@
                 </a:solidFill>
                 <a:latin typeface="Arial"/>
               </a:rPr>
-              <a:t>Revoir les titres petite enfance et éveil à la foi</a:t>
+              <a:t>Revoir les annonces petite enfance et génériques</a:t>
             </a:r>
           </a:p>
         </p:txBody>
@@ -7517,7 +7324,7 @@
                 </a:solidFill>
                 <a:latin typeface="Arial"/>
               </a:rPr>
-              <a:t>Les Belles Histoires, Babar, Astrapi et Mon p'tit Prions en Église restent entre 0,62 et 0,67 fois la moyenne.</a:t>
+              <a:t>L'éveil et la petite enfance représentent 40 % de la diffusion mais restent à 0,92 fois la moyenne (Les Belles Histoires 0,62 fois, Babar 0,67 fois). Les annonces génériques sont à 0,89 fois.</a:t>
             </a:r>
           </a:p>
         </p:txBody>
@@ -7552,7 +7359,7 @@
                 </a:solidFill>
                 <a:latin typeface="Arial"/>
               </a:rPr>
-              <a:t>→  Tester des messages plus orientés parents (rituel du soir, temps partagé).</a:t>
+              <a:t>→  Parler aux parents d'un moment précis (histoire du soir, premiers apprentissages) plutôt que de l'abonnement en général.</a:t>
             </a:r>
           </a:p>
         </p:txBody>
@@ -7738,7 +7545,7 @@
                 </a:solidFill>
                 <a:latin typeface="Arial"/>
               </a:rPr>
-              <a:t>→  Prolonger la campagne au-delà du 11/10 pour la période des cadeaux de fin d'année.</a:t>
+              <a:t>→  Prolonger la campagne au-delà du 11/10, pour la période des cadeaux de fin d'année.</a:t>
             </a:r>
           </a:p>
         </p:txBody>

</xml_diff>